<commit_message>
Add 2D heat solver, validation, and animation improvements
Replaces 2d_heat.py with solve_2d_heat.py, introducing a parameterized 2D heat equation solver with improved boundary and source handling, and LU factorization for efficiency. Adds validate_2d.py for automated comparison with an exact solution. Enhances plotting_2d.py with comparison and animation utilities. Updates 1d_transient_poisson.py to use matplotlib animation and save output. Improves quadrature and boundary integration in matrices_2d.py and corrects element edge plotting in geometry_2d.py. Adds new figures, presentation, and animation output files.
</commit_message>
<xml_diff>
--- a/FEA/Final_Project/Figures/boundary_integral.pptx
+++ b/FEA/Final_Project/Figures/boundary_integral.pptx
@@ -243,7 +243,7 @@
           <a:p>
             <a:fld id="{71E374CD-6BE6-4F71-8AD2-0DBADDA61E3E}" type="datetimeFigureOut">
               <a:rPr lang="en-US" smtClean="0"/>
-              <a:t>11/21/2025</a:t>
+              <a:t>11/24/2025</a:t>
             </a:fld>
             <a:endParaRPr lang="en-US"/>
           </a:p>
@@ -413,7 +413,7 @@
           <a:p>
             <a:fld id="{71E374CD-6BE6-4F71-8AD2-0DBADDA61E3E}" type="datetimeFigureOut">
               <a:rPr lang="en-US" smtClean="0"/>
-              <a:t>11/21/2025</a:t>
+              <a:t>11/24/2025</a:t>
             </a:fld>
             <a:endParaRPr lang="en-US"/>
           </a:p>
@@ -593,7 +593,7 @@
           <a:p>
             <a:fld id="{71E374CD-6BE6-4F71-8AD2-0DBADDA61E3E}" type="datetimeFigureOut">
               <a:rPr lang="en-US" smtClean="0"/>
-              <a:t>11/21/2025</a:t>
+              <a:t>11/24/2025</a:t>
             </a:fld>
             <a:endParaRPr lang="en-US"/>
           </a:p>
@@ -763,7 +763,7 @@
           <a:p>
             <a:fld id="{71E374CD-6BE6-4F71-8AD2-0DBADDA61E3E}" type="datetimeFigureOut">
               <a:rPr lang="en-US" smtClean="0"/>
-              <a:t>11/21/2025</a:t>
+              <a:t>11/24/2025</a:t>
             </a:fld>
             <a:endParaRPr lang="en-US"/>
           </a:p>
@@ -1009,7 +1009,7 @@
           <a:p>
             <a:fld id="{71E374CD-6BE6-4F71-8AD2-0DBADDA61E3E}" type="datetimeFigureOut">
               <a:rPr lang="en-US" smtClean="0"/>
-              <a:t>11/21/2025</a:t>
+              <a:t>11/24/2025</a:t>
             </a:fld>
             <a:endParaRPr lang="en-US"/>
           </a:p>
@@ -1241,7 +1241,7 @@
           <a:p>
             <a:fld id="{71E374CD-6BE6-4F71-8AD2-0DBADDA61E3E}" type="datetimeFigureOut">
               <a:rPr lang="en-US" smtClean="0"/>
-              <a:t>11/21/2025</a:t>
+              <a:t>11/24/2025</a:t>
             </a:fld>
             <a:endParaRPr lang="en-US"/>
           </a:p>
@@ -1608,7 +1608,7 @@
           <a:p>
             <a:fld id="{71E374CD-6BE6-4F71-8AD2-0DBADDA61E3E}" type="datetimeFigureOut">
               <a:rPr lang="en-US" smtClean="0"/>
-              <a:t>11/21/2025</a:t>
+              <a:t>11/24/2025</a:t>
             </a:fld>
             <a:endParaRPr lang="en-US"/>
           </a:p>
@@ -1726,7 +1726,7 @@
           <a:p>
             <a:fld id="{71E374CD-6BE6-4F71-8AD2-0DBADDA61E3E}" type="datetimeFigureOut">
               <a:rPr lang="en-US" smtClean="0"/>
-              <a:t>11/21/2025</a:t>
+              <a:t>11/24/2025</a:t>
             </a:fld>
             <a:endParaRPr lang="en-US"/>
           </a:p>
@@ -1821,7 +1821,7 @@
           <a:p>
             <a:fld id="{71E374CD-6BE6-4F71-8AD2-0DBADDA61E3E}" type="datetimeFigureOut">
               <a:rPr lang="en-US" smtClean="0"/>
-              <a:t>11/21/2025</a:t>
+              <a:t>11/24/2025</a:t>
             </a:fld>
             <a:endParaRPr lang="en-US"/>
           </a:p>
@@ -2098,7 +2098,7 @@
           <a:p>
             <a:fld id="{71E374CD-6BE6-4F71-8AD2-0DBADDA61E3E}" type="datetimeFigureOut">
               <a:rPr lang="en-US" smtClean="0"/>
-              <a:t>11/21/2025</a:t>
+              <a:t>11/24/2025</a:t>
             </a:fld>
             <a:endParaRPr lang="en-US"/>
           </a:p>
@@ -2355,7 +2355,7 @@
           <a:p>
             <a:fld id="{71E374CD-6BE6-4F71-8AD2-0DBADDA61E3E}" type="datetimeFigureOut">
               <a:rPr lang="en-US" smtClean="0"/>
-              <a:t>11/21/2025</a:t>
+              <a:t>11/24/2025</a:t>
             </a:fld>
             <a:endParaRPr lang="en-US"/>
           </a:p>
@@ -2568,7 +2568,7 @@
           <a:p>
             <a:fld id="{71E374CD-6BE6-4F71-8AD2-0DBADDA61E3E}" type="datetimeFigureOut">
               <a:rPr lang="en-US" smtClean="0"/>
-              <a:t>11/21/2025</a:t>
+              <a:t>11/24/2025</a:t>
             </a:fld>
             <a:endParaRPr lang="en-US"/>
           </a:p>
@@ -2975,244 +2975,6 @@
       </p:grpSpPr>
       <p:cxnSp>
         <p:nvCxnSpPr>
-          <p:cNvPr id="7" name="Straight Arrow Connector 6">
-            <a:extLst>
-              <a:ext uri="{FF2B5EF4-FFF2-40B4-BE49-F238E27FC236}">
-                <a16:creationId xmlns:a16="http://schemas.microsoft.com/office/drawing/2014/main" id="{DA8A1048-1453-EC06-22EF-2FAE140A91C2}"/>
-              </a:ext>
-            </a:extLst>
-          </p:cNvPr>
-          <p:cNvCxnSpPr/>
-          <p:nvPr/>
-        </p:nvCxnSpPr>
-        <p:spPr>
-          <a:xfrm>
-            <a:off x="323850" y="4121150"/>
-            <a:ext cx="4978400" cy="0"/>
-          </a:xfrm>
-          <a:prstGeom prst="straightConnector1">
-            <a:avLst/>
-          </a:prstGeom>
-          <a:ln>
-            <a:headEnd type="triangle"/>
-            <a:tailEnd type="triangle"/>
-          </a:ln>
-        </p:spPr>
-        <p:style>
-          <a:lnRef idx="2">
-            <a:schemeClr val="dk1"/>
-          </a:lnRef>
-          <a:fillRef idx="0">
-            <a:schemeClr val="dk1"/>
-          </a:fillRef>
-          <a:effectRef idx="1">
-            <a:schemeClr val="dk1"/>
-          </a:effectRef>
-          <a:fontRef idx="minor">
-            <a:schemeClr val="tx1"/>
-          </a:fontRef>
-        </p:style>
-      </p:cxnSp>
-      <mc:AlternateContent xmlns:mc="http://schemas.openxmlformats.org/markup-compatibility/2006" xmlns:a14="http://schemas.microsoft.com/office/drawing/2010/main">
-        <mc:Choice Requires="a14">
-          <p:sp>
-            <p:nvSpPr>
-              <p:cNvPr id="8" name="TextBox 7">
-                <a:extLst>
-                  <a:ext uri="{FF2B5EF4-FFF2-40B4-BE49-F238E27FC236}">
-                    <a16:creationId xmlns:a16="http://schemas.microsoft.com/office/drawing/2014/main" id="{3BE3C2C4-2C8A-6A26-A029-8F962C7E048C}"/>
-                  </a:ext>
-                </a:extLst>
-              </p:cNvPr>
-              <p:cNvSpPr txBox="1"/>
-              <p:nvPr/>
-            </p:nvSpPr>
-            <p:spPr>
-              <a:xfrm>
-                <a:off x="5222933" y="4070350"/>
-                <a:ext cx="158633" cy="276999"/>
-              </a:xfrm>
-              <a:prstGeom prst="rect">
-                <a:avLst/>
-              </a:prstGeom>
-              <a:noFill/>
-            </p:spPr>
-            <p:txBody>
-              <a:bodyPr wrap="none" lIns="0" tIns="0" rIns="0" bIns="0" rtlCol="0">
-                <a:spAutoFit/>
-              </a:bodyPr>
-              <a:lstStyle/>
-              <a:p>
-                <a:pPr/>
-                <a14:m>
-                  <m:oMathPara xmlns:m="http://schemas.openxmlformats.org/officeDocument/2006/math">
-                    <m:oMathParaPr>
-                      <m:jc m:val="centerGroup"/>
-                    </m:oMathParaPr>
-                    <m:oMath xmlns:m="http://schemas.openxmlformats.org/officeDocument/2006/math">
-                      <m:r>
-                        <a:rPr lang="en-US" b="0" i="1" smtClean="0">
-                          <a:latin typeface="Cambria Math" panose="02040503050406030204" pitchFamily="18" charset="0"/>
-                        </a:rPr>
-                        <m:t>𝑠</m:t>
-                      </m:r>
-                    </m:oMath>
-                  </m:oMathPara>
-                </a14:m>
-                <a:endParaRPr lang="en-US" b="0" dirty="0"/>
-              </a:p>
-            </p:txBody>
-          </p:sp>
-        </mc:Choice>
-        <mc:Fallback xmlns="">
-          <p:sp>
-            <p:nvSpPr>
-              <p:cNvPr id="8" name="TextBox 7">
-                <a:extLst>
-                  <a:ext uri="{FF2B5EF4-FFF2-40B4-BE49-F238E27FC236}">
-                    <a16:creationId xmlns:a16="http://schemas.microsoft.com/office/drawing/2014/main" id="{3BE3C2C4-2C8A-6A26-A029-8F962C7E048C}"/>
-                  </a:ext>
-                </a:extLst>
-              </p:cNvPr>
-              <p:cNvSpPr txBox="1">
-                <a:spLocks noRot="1" noChangeAspect="1" noMove="1" noResize="1" noEditPoints="1" noAdjustHandles="1" noChangeArrowheads="1" noChangeShapeType="1" noTextEdit="1"/>
-              </p:cNvSpPr>
-              <p:nvPr/>
-            </p:nvSpPr>
-            <p:spPr>
-              <a:xfrm>
-                <a:off x="5222933" y="4070350"/>
-                <a:ext cx="158633" cy="276999"/>
-              </a:xfrm>
-              <a:prstGeom prst="rect">
-                <a:avLst/>
-              </a:prstGeom>
-              <a:blipFill>
-                <a:blip r:embed="rId2"/>
-                <a:stretch>
-                  <a:fillRect l="-23077" r="-23077"/>
-                </a:stretch>
-              </a:blipFill>
-            </p:spPr>
-            <p:txBody>
-              <a:bodyPr/>
-              <a:lstStyle/>
-              <a:p>
-                <a:r>
-                  <a:rPr lang="en-US">
-                    <a:noFill/>
-                  </a:rPr>
-                  <a:t> </a:t>
-                </a:r>
-              </a:p>
-            </p:txBody>
-          </p:sp>
-        </mc:Fallback>
-      </mc:AlternateContent>
-      <mc:AlternateContent xmlns:mc="http://schemas.openxmlformats.org/markup-compatibility/2006" xmlns:a14="http://schemas.microsoft.com/office/drawing/2010/main">
-        <mc:Choice Requires="a14">
-          <p:sp>
-            <p:nvSpPr>
-              <p:cNvPr id="15" name="TextBox 14">
-                <a:extLst>
-                  <a:ext uri="{FF2B5EF4-FFF2-40B4-BE49-F238E27FC236}">
-                    <a16:creationId xmlns:a16="http://schemas.microsoft.com/office/drawing/2014/main" id="{049E437F-5F90-5F6D-DC94-A18747D4328F}"/>
-                  </a:ext>
-                </a:extLst>
-              </p:cNvPr>
-              <p:cNvSpPr txBox="1"/>
-              <p:nvPr/>
-            </p:nvSpPr>
-            <p:spPr>
-              <a:xfrm>
-                <a:off x="2518931" y="4208849"/>
-                <a:ext cx="588238" cy="276999"/>
-              </a:xfrm>
-              <a:prstGeom prst="rect">
-                <a:avLst/>
-              </a:prstGeom>
-              <a:noFill/>
-            </p:spPr>
-            <p:txBody>
-              <a:bodyPr wrap="none" lIns="0" tIns="0" rIns="0" bIns="0" rtlCol="0">
-                <a:spAutoFit/>
-              </a:bodyPr>
-              <a:lstStyle/>
-              <a:p>
-                <a:pPr/>
-                <a14:m>
-                  <m:oMathPara xmlns:m="http://schemas.openxmlformats.org/officeDocument/2006/math">
-                    <m:oMathParaPr>
-                      <m:jc m:val="centerGroup"/>
-                    </m:oMathParaPr>
-                    <m:oMath xmlns:m="http://schemas.openxmlformats.org/officeDocument/2006/math">
-                      <m:r>
-                        <a:rPr lang="en-US" b="0" i="1" smtClean="0">
-                          <a:latin typeface="Cambria Math" panose="02040503050406030204" pitchFamily="18" charset="0"/>
-                        </a:rPr>
-                        <m:t>𝑠</m:t>
-                      </m:r>
-                      <m:r>
-                        <a:rPr lang="en-US" b="0" i="1" smtClean="0">
-                          <a:latin typeface="Cambria Math" panose="02040503050406030204" pitchFamily="18" charset="0"/>
-                        </a:rPr>
-                        <m:t>=0</m:t>
-                      </m:r>
-                    </m:oMath>
-                  </m:oMathPara>
-                </a14:m>
-                <a:endParaRPr lang="en-US" dirty="0"/>
-              </a:p>
-            </p:txBody>
-          </p:sp>
-        </mc:Choice>
-        <mc:Fallback xmlns="">
-          <p:sp>
-            <p:nvSpPr>
-              <p:cNvPr id="15" name="TextBox 14">
-                <a:extLst>
-                  <a:ext uri="{FF2B5EF4-FFF2-40B4-BE49-F238E27FC236}">
-                    <a16:creationId xmlns:a16="http://schemas.microsoft.com/office/drawing/2014/main" id="{049E437F-5F90-5F6D-DC94-A18747D4328F}"/>
-                  </a:ext>
-                </a:extLst>
-              </p:cNvPr>
-              <p:cNvSpPr txBox="1">
-                <a:spLocks noRot="1" noChangeAspect="1" noMove="1" noResize="1" noEditPoints="1" noAdjustHandles="1" noChangeArrowheads="1" noChangeShapeType="1" noTextEdit="1"/>
-              </p:cNvSpPr>
-              <p:nvPr/>
-            </p:nvSpPr>
-            <p:spPr>
-              <a:xfrm>
-                <a:off x="2518931" y="4208849"/>
-                <a:ext cx="588238" cy="276999"/>
-              </a:xfrm>
-              <a:prstGeom prst="rect">
-                <a:avLst/>
-              </a:prstGeom>
-              <a:blipFill>
-                <a:blip r:embed="rId3"/>
-                <a:stretch>
-                  <a:fillRect l="-6186" r="-9278" b="-6522"/>
-                </a:stretch>
-              </a:blipFill>
-            </p:spPr>
-            <p:txBody>
-              <a:bodyPr/>
-              <a:lstStyle/>
-              <a:p>
-                <a:r>
-                  <a:rPr lang="en-US">
-                    <a:noFill/>
-                  </a:rPr>
-                  <a:t> </a:t>
-                </a:r>
-              </a:p>
-            </p:txBody>
-          </p:sp>
-        </mc:Fallback>
-      </mc:AlternateContent>
-      <p:cxnSp>
-        <p:nvCxnSpPr>
           <p:cNvPr id="19" name="Straight Connector 18">
             <a:extLst>
               <a:ext uri="{FF2B5EF4-FFF2-40B4-BE49-F238E27FC236}">
@@ -3233,6 +2995,13 @@
           <a:prstGeom prst="line">
             <a:avLst/>
           </a:prstGeom>
+          <a:ln>
+            <a:solidFill>
+              <a:schemeClr val="accent6">
+                <a:lumMod val="75000"/>
+              </a:schemeClr>
+            </a:solidFill>
+          </a:ln>
         </p:spPr>
         <p:style>
           <a:lnRef idx="2">
@@ -3637,8 +3406,8 @@
           </a:prstGeom>
           <a:ln>
             <a:solidFill>
-              <a:schemeClr val="bg2">
-                <a:lumMod val="50000"/>
+              <a:schemeClr val="accent6">
+                <a:lumMod val="75000"/>
               </a:schemeClr>
             </a:solidFill>
           </a:ln>
@@ -3682,8 +3451,8 @@
           </a:prstGeom>
           <a:ln>
             <a:solidFill>
-              <a:schemeClr val="bg2">
-                <a:lumMod val="50000"/>
+              <a:schemeClr val="accent1">
+                <a:lumMod val="75000"/>
               </a:schemeClr>
             </a:solidFill>
           </a:ln>
@@ -3703,8 +3472,8 @@
           </a:fontRef>
         </p:style>
       </p:cxnSp>
-      <mc:AlternateContent xmlns:mc="http://schemas.openxmlformats.org/markup-compatibility/2006" xmlns:a14="http://schemas.microsoft.com/office/drawing/2010/main">
-        <mc:Choice Requires="a14">
+      <mc:AlternateContent xmlns:mc="http://schemas.openxmlformats.org/markup-compatibility/2006">
+        <mc:Choice xmlns:a14="http://schemas.microsoft.com/office/drawing/2010/main" Requires="a14">
           <p:sp>
             <p:nvSpPr>
               <p:cNvPr id="38" name="TextBox 37">
@@ -3719,8 +3488,8 @@
             </p:nvSpPr>
             <p:spPr>
               <a:xfrm>
-                <a:off x="1250950" y="2787650"/>
-                <a:ext cx="736933" cy="276999"/>
+                <a:off x="1219200" y="2764105"/>
+                <a:ext cx="833882" cy="276999"/>
               </a:xfrm>
               <a:prstGeom prst="rect">
                 <a:avLst/>
@@ -3791,17 +3560,46 @@
                         </a:rPr>
                         <m:t>(</m:t>
                       </m:r>
-                      <m:r>
-                        <a:rPr lang="en-US" b="0" i="1" smtClean="0">
-                          <a:solidFill>
-                            <a:schemeClr val="bg2">
-                              <a:lumMod val="50000"/>
-                            </a:schemeClr>
-                          </a:solidFill>
-                          <a:latin typeface="Cambria Math" panose="02040503050406030204" pitchFamily="18" charset="0"/>
-                        </a:rPr>
-                        <m:t>𝑠</m:t>
-                      </m:r>
+                      <m:sSub>
+                        <m:sSubPr>
+                          <m:ctrlPr>
+                            <a:rPr lang="en-US" b="0" i="1" smtClean="0">
+                              <a:solidFill>
+                                <a:schemeClr val="bg2">
+                                  <a:lumMod val="50000"/>
+                                </a:schemeClr>
+                              </a:solidFill>
+                              <a:latin typeface="Cambria Math" panose="02040503050406030204" pitchFamily="18" charset="0"/>
+                            </a:rPr>
+                          </m:ctrlPr>
+                        </m:sSubPr>
+                        <m:e>
+                          <m:r>
+                            <a:rPr lang="en-US" b="0" i="1" smtClean="0">
+                              <a:solidFill>
+                                <a:schemeClr val="bg2">
+                                  <a:lumMod val="50000"/>
+                                </a:schemeClr>
+                              </a:solidFill>
+                              <a:latin typeface="Cambria Math" panose="02040503050406030204" pitchFamily="18" charset="0"/>
+                            </a:rPr>
+                            <m:t>𝑠</m:t>
+                          </m:r>
+                        </m:e>
+                        <m:sub>
+                          <m:r>
+                            <a:rPr lang="en-US" b="0" i="1" smtClean="0">
+                              <a:solidFill>
+                                <a:schemeClr val="bg2">
+                                  <a:lumMod val="50000"/>
+                                </a:schemeClr>
+                              </a:solidFill>
+                              <a:latin typeface="Cambria Math" panose="02040503050406030204" pitchFamily="18" charset="0"/>
+                            </a:rPr>
+                            <m:t>2</m:t>
+                          </m:r>
+                        </m:sub>
+                      </m:sSub>
                       <m:r>
                         <a:rPr lang="en-US" b="0" i="1" smtClean="0">
                           <a:solidFill>
@@ -3827,7 +3625,7 @@
             </p:txBody>
           </p:sp>
         </mc:Choice>
-        <mc:Fallback xmlns="">
+        <mc:Fallback>
           <p:sp>
             <p:nvSpPr>
               <p:cNvPr id="38" name="TextBox 37">
@@ -3844,8 +3642,8 @@
             </p:nvSpPr>
             <p:spPr>
               <a:xfrm>
-                <a:off x="1250950" y="2787650"/>
-                <a:ext cx="736933" cy="276999"/>
+                <a:off x="1219200" y="2764105"/>
+                <a:ext cx="833882" cy="276999"/>
               </a:xfrm>
               <a:prstGeom prst="rect">
                 <a:avLst/>
@@ -3853,7 +3651,7 @@
               <a:blipFill>
                 <a:blip r:embed="rId7"/>
                 <a:stretch>
-                  <a:fillRect l="-10744" t="-2174" r="-11570" b="-32609"/>
+                  <a:fillRect l="-9489" t="-2174" r="-10219" b="-32609"/>
                 </a:stretch>
               </a:blipFill>
             </p:spPr>
@@ -3872,8 +3670,8 @@
           </p:sp>
         </mc:Fallback>
       </mc:AlternateContent>
-      <mc:AlternateContent xmlns:mc="http://schemas.openxmlformats.org/markup-compatibility/2006" xmlns:a14="http://schemas.microsoft.com/office/drawing/2010/main">
-        <mc:Choice Requires="a14">
+      <mc:AlternateContent xmlns:mc="http://schemas.openxmlformats.org/markup-compatibility/2006">
+        <mc:Choice xmlns:a14="http://schemas.microsoft.com/office/drawing/2010/main" Requires="a14">
           <p:sp>
             <p:nvSpPr>
               <p:cNvPr id="39" name="TextBox 38">
@@ -3888,8 +3686,8 @@
             </p:nvSpPr>
             <p:spPr>
               <a:xfrm>
-                <a:off x="3866983" y="2787650"/>
-                <a:ext cx="777585" cy="276999"/>
+                <a:off x="3820086" y="2902604"/>
+                <a:ext cx="869212" cy="276999"/>
               </a:xfrm>
               <a:prstGeom prst="rect">
                 <a:avLst/>
@@ -3960,17 +3758,46 @@
                         </a:rPr>
                         <m:t>(</m:t>
                       </m:r>
-                      <m:r>
-                        <a:rPr lang="en-US" b="0" i="1" smtClean="0">
-                          <a:solidFill>
-                            <a:schemeClr val="bg2">
-                              <a:lumMod val="50000"/>
-                            </a:schemeClr>
-                          </a:solidFill>
-                          <a:latin typeface="Cambria Math" panose="02040503050406030204" pitchFamily="18" charset="0"/>
-                        </a:rPr>
-                        <m:t>𝑠</m:t>
-                      </m:r>
+                      <m:sSub>
+                        <m:sSubPr>
+                          <m:ctrlPr>
+                            <a:rPr lang="en-US" b="0" i="1" smtClean="0">
+                              <a:solidFill>
+                                <a:schemeClr val="bg2">
+                                  <a:lumMod val="50000"/>
+                                </a:schemeClr>
+                              </a:solidFill>
+                              <a:latin typeface="Cambria Math" panose="02040503050406030204" pitchFamily="18" charset="0"/>
+                            </a:rPr>
+                          </m:ctrlPr>
+                        </m:sSubPr>
+                        <m:e>
+                          <m:r>
+                            <a:rPr lang="en-US" b="0" i="1" smtClean="0">
+                              <a:solidFill>
+                                <a:schemeClr val="bg2">
+                                  <a:lumMod val="50000"/>
+                                </a:schemeClr>
+                              </a:solidFill>
+                              <a:latin typeface="Cambria Math" panose="02040503050406030204" pitchFamily="18" charset="0"/>
+                            </a:rPr>
+                            <m:t>𝑠</m:t>
+                          </m:r>
+                        </m:e>
+                        <m:sub>
+                          <m:r>
+                            <a:rPr lang="en-US" b="0" i="1" smtClean="0">
+                              <a:solidFill>
+                                <a:schemeClr val="bg2">
+                                  <a:lumMod val="50000"/>
+                                </a:schemeClr>
+                              </a:solidFill>
+                              <a:latin typeface="Cambria Math" panose="02040503050406030204" pitchFamily="18" charset="0"/>
+                            </a:rPr>
+                            <m:t>1</m:t>
+                          </m:r>
+                        </m:sub>
+                      </m:sSub>
                       <m:r>
                         <a:rPr lang="en-US" b="0" i="1" smtClean="0">
                           <a:solidFill>
@@ -3996,7 +3823,7 @@
             </p:txBody>
           </p:sp>
         </mc:Choice>
-        <mc:Fallback xmlns="">
+        <mc:Fallback>
           <p:sp>
             <p:nvSpPr>
               <p:cNvPr id="39" name="TextBox 38">
@@ -4013,8 +3840,8 @@
             </p:nvSpPr>
             <p:spPr>
               <a:xfrm>
-                <a:off x="3866983" y="2787650"/>
-                <a:ext cx="777585" cy="276999"/>
+                <a:off x="3820086" y="2902604"/>
+                <a:ext cx="869212" cy="276999"/>
               </a:xfrm>
               <a:prstGeom prst="rect">
                 <a:avLst/>
@@ -4022,7 +3849,7 @@
               <a:blipFill>
                 <a:blip r:embed="rId8"/>
                 <a:stretch>
-                  <a:fillRect l="-10156" t="-2174" r="-10938" b="-32609"/>
+                  <a:fillRect l="-9859" t="-2174" r="-10563" b="-32609"/>
                 </a:stretch>
               </a:blipFill>
             </p:spPr>
@@ -4398,8 +4225,8 @@
           </a:p>
         </p:txBody>
       </p:sp>
-      <mc:AlternateContent xmlns:mc="http://schemas.openxmlformats.org/markup-compatibility/2006" xmlns:a14="http://schemas.microsoft.com/office/drawing/2010/main">
-        <mc:Choice Requires="a14">
+      <mc:AlternateContent xmlns:mc="http://schemas.openxmlformats.org/markup-compatibility/2006">
+        <mc:Choice xmlns:a14="http://schemas.microsoft.com/office/drawing/2010/main" Requires="a14">
           <p:sp>
             <p:nvSpPr>
               <p:cNvPr id="47" name="TextBox 46">
@@ -4414,19 +4241,17 @@
             </p:nvSpPr>
             <p:spPr>
               <a:xfrm>
-                <a:off x="2571541" y="704553"/>
-                <a:ext cx="483017" cy="276999"/>
+                <a:off x="2825750" y="819946"/>
+                <a:ext cx="178510" cy="276999"/>
               </a:xfrm>
               <a:prstGeom prst="rect">
                 <a:avLst/>
               </a:prstGeom>
-              <a:noFill/>
+              <a:solidFill>
+                <a:schemeClr val="bg1"/>
+              </a:solidFill>
               <a:ln>
-                <a:solidFill>
-                  <a:schemeClr val="bg2">
-                    <a:lumMod val="75000"/>
-                  </a:schemeClr>
-                </a:solidFill>
+                <a:noFill/>
               </a:ln>
             </p:spPr>
             <p:txBody>
@@ -4453,39 +4278,6 @@
                         </a:rPr>
                         <m:t>𝑞</m:t>
                       </m:r>
-                      <m:r>
-                        <a:rPr lang="en-US" b="0" i="1" smtClean="0">
-                          <a:solidFill>
-                            <a:schemeClr val="bg2">
-                              <a:lumMod val="50000"/>
-                            </a:schemeClr>
-                          </a:solidFill>
-                          <a:latin typeface="Cambria Math" panose="02040503050406030204" pitchFamily="18" charset="0"/>
-                        </a:rPr>
-                        <m:t>(</m:t>
-                      </m:r>
-                      <m:r>
-                        <a:rPr lang="en-US" b="0" i="1" smtClean="0">
-                          <a:solidFill>
-                            <a:schemeClr val="bg2">
-                              <a:lumMod val="50000"/>
-                            </a:schemeClr>
-                          </a:solidFill>
-                          <a:latin typeface="Cambria Math" panose="02040503050406030204" pitchFamily="18" charset="0"/>
-                        </a:rPr>
-                        <m:t>𝑠</m:t>
-                      </m:r>
-                      <m:r>
-                        <a:rPr lang="en-US" b="0" i="1" smtClean="0">
-                          <a:solidFill>
-                            <a:schemeClr val="bg2">
-                              <a:lumMod val="50000"/>
-                            </a:schemeClr>
-                          </a:solidFill>
-                          <a:latin typeface="Cambria Math" panose="02040503050406030204" pitchFamily="18" charset="0"/>
-                        </a:rPr>
-                        <m:t>)</m:t>
-                      </m:r>
                     </m:oMath>
                   </m:oMathPara>
                 </a14:m>
@@ -4500,7 +4292,7 @@
             </p:txBody>
           </p:sp>
         </mc:Choice>
-        <mc:Fallback xmlns="">
+        <mc:Fallback>
           <p:sp>
             <p:nvSpPr>
               <p:cNvPr id="47" name="TextBox 46">
@@ -4517,8 +4309,8 @@
             </p:nvSpPr>
             <p:spPr>
               <a:xfrm>
-                <a:off x="2571541" y="704553"/>
-                <a:ext cx="483017" cy="276999"/>
+                <a:off x="2825750" y="819946"/>
+                <a:ext cx="178510" cy="276999"/>
               </a:xfrm>
               <a:prstGeom prst="rect">
                 <a:avLst/>
@@ -4526,15 +4318,858 @@
               <a:blipFill>
                 <a:blip r:embed="rId9"/>
                 <a:stretch>
-                  <a:fillRect l="-11111" t="-2128" r="-17284" b="-31915"/>
+                  <a:fillRect l="-34483" r="-31034" b="-26667"/>
+                </a:stretch>
+              </a:blipFill>
+              <a:ln>
+                <a:noFill/>
+              </a:ln>
+            </p:spPr>
+            <p:txBody>
+              <a:bodyPr/>
+              <a:lstStyle/>
+              <a:p>
+                <a:r>
+                  <a:rPr lang="en-US">
+                    <a:noFill/>
+                  </a:rPr>
+                  <a:t> </a:t>
+                </a:r>
+              </a:p>
+            </p:txBody>
+          </p:sp>
+        </mc:Fallback>
+      </mc:AlternateContent>
+      <p:cxnSp>
+        <p:nvCxnSpPr>
+          <p:cNvPr id="3" name="Straight Arrow Connector 2">
+            <a:extLst>
+              <a:ext uri="{FF2B5EF4-FFF2-40B4-BE49-F238E27FC236}">
+                <a16:creationId xmlns:a16="http://schemas.microsoft.com/office/drawing/2014/main" id="{67F8BD60-9124-F9A0-256A-1A2DA8F751FD}"/>
+              </a:ext>
+            </a:extLst>
+          </p:cNvPr>
+          <p:cNvCxnSpPr/>
+          <p:nvPr/>
+        </p:nvCxnSpPr>
+        <p:spPr>
+          <a:xfrm flipH="1">
+            <a:off x="485980" y="69850"/>
+            <a:ext cx="4652923" cy="0"/>
+          </a:xfrm>
+          <a:prstGeom prst="straightConnector1">
+            <a:avLst/>
+          </a:prstGeom>
+          <a:ln>
+            <a:solidFill>
+              <a:schemeClr val="bg2">
+                <a:lumMod val="75000"/>
+              </a:schemeClr>
+            </a:solidFill>
+            <a:headEnd type="arrow" w="med" len="med"/>
+            <a:tailEnd type="none" w="med" len="med"/>
+          </a:ln>
+        </p:spPr>
+        <p:style>
+          <a:lnRef idx="2">
+            <a:schemeClr val="accent1"/>
+          </a:lnRef>
+          <a:fillRef idx="0">
+            <a:schemeClr val="accent1"/>
+          </a:fillRef>
+          <a:effectRef idx="1">
+            <a:schemeClr val="accent1"/>
+          </a:effectRef>
+          <a:fontRef idx="minor">
+            <a:schemeClr val="tx1"/>
+          </a:fontRef>
+        </p:style>
+      </p:cxnSp>
+      <mc:AlternateContent xmlns:mc="http://schemas.openxmlformats.org/markup-compatibility/2006">
+        <mc:Choice xmlns:a14="http://schemas.microsoft.com/office/drawing/2010/main" Requires="a14">
+          <p:sp>
+            <p:nvSpPr>
+              <p:cNvPr id="4" name="TextBox 3">
+                <a:extLst>
+                  <a:ext uri="{FF2B5EF4-FFF2-40B4-BE49-F238E27FC236}">
+                    <a16:creationId xmlns:a16="http://schemas.microsoft.com/office/drawing/2014/main" id="{99C2914F-5D5C-C6FE-D731-9C3363BF3DFA}"/>
+                  </a:ext>
+                </a:extLst>
+              </p:cNvPr>
+              <p:cNvSpPr txBox="1"/>
+              <p:nvPr/>
+            </p:nvSpPr>
+            <p:spPr>
+              <a:xfrm>
+                <a:off x="5057806" y="127602"/>
+                <a:ext cx="180306" cy="276999"/>
+              </a:xfrm>
+              <a:prstGeom prst="rect">
+                <a:avLst/>
+              </a:prstGeom>
+              <a:solidFill>
+                <a:schemeClr val="bg1"/>
+              </a:solidFill>
+              <a:ln>
+                <a:noFill/>
+              </a:ln>
+            </p:spPr>
+            <p:txBody>
+              <a:bodyPr wrap="none" lIns="0" tIns="0" rIns="0" bIns="0" rtlCol="0">
+                <a:spAutoFit/>
+              </a:bodyPr>
+              <a:lstStyle/>
+              <a:p>
+                <a:pPr/>
+                <a14:m>
+                  <m:oMathPara xmlns:m="http://schemas.openxmlformats.org/officeDocument/2006/math">
+                    <m:oMathParaPr>
+                      <m:jc m:val="centerGroup"/>
+                    </m:oMathParaPr>
+                    <m:oMath xmlns:m="http://schemas.openxmlformats.org/officeDocument/2006/math">
+                      <m:r>
+                        <a:rPr lang="en-US" b="0" i="1" smtClean="0">
+                          <a:solidFill>
+                            <a:schemeClr val="bg2">
+                              <a:lumMod val="50000"/>
+                            </a:schemeClr>
+                          </a:solidFill>
+                          <a:latin typeface="Cambria Math" panose="02040503050406030204" pitchFamily="18" charset="0"/>
+                        </a:rPr>
+                        <m:t>𝑦</m:t>
+                      </m:r>
+                    </m:oMath>
+                  </m:oMathPara>
+                </a14:m>
+                <a:endParaRPr lang="en-US" dirty="0">
+                  <a:solidFill>
+                    <a:schemeClr val="bg2">
+                      <a:lumMod val="50000"/>
+                    </a:schemeClr>
+                  </a:solidFill>
+                </a:endParaRPr>
+              </a:p>
+            </p:txBody>
+          </p:sp>
+        </mc:Choice>
+        <mc:Fallback>
+          <p:sp>
+            <p:nvSpPr>
+              <p:cNvPr id="4" name="TextBox 3">
+                <a:extLst>
+                  <a:ext uri="{FF2B5EF4-FFF2-40B4-BE49-F238E27FC236}">
+                    <a16:creationId xmlns:a16="http://schemas.microsoft.com/office/drawing/2014/main" id="{99C2914F-5D5C-C6FE-D731-9C3363BF3DFA}"/>
+                  </a:ext>
+                </a:extLst>
+              </p:cNvPr>
+              <p:cNvSpPr txBox="1">
+                <a:spLocks noRot="1" noChangeAspect="1" noMove="1" noResize="1" noEditPoints="1" noAdjustHandles="1" noChangeArrowheads="1" noChangeShapeType="1" noTextEdit="1"/>
+              </p:cNvSpPr>
+              <p:nvPr/>
+            </p:nvSpPr>
+            <p:spPr>
+              <a:xfrm>
+                <a:off x="5057806" y="127602"/>
+                <a:ext cx="180306" cy="276999"/>
+              </a:xfrm>
+              <a:prstGeom prst="rect">
+                <a:avLst/>
+              </a:prstGeom>
+              <a:blipFill>
+                <a:blip r:embed="rId10"/>
+                <a:stretch>
+                  <a:fillRect l="-34483" r="-34483" b="-26667"/>
+                </a:stretch>
+              </a:blipFill>
+              <a:ln>
+                <a:noFill/>
+              </a:ln>
+            </p:spPr>
+            <p:txBody>
+              <a:bodyPr/>
+              <a:lstStyle/>
+              <a:p>
+                <a:r>
+                  <a:rPr lang="en-US">
+                    <a:noFill/>
+                  </a:rPr>
+                  <a:t> </a:t>
+                </a:r>
+              </a:p>
+            </p:txBody>
+          </p:sp>
+        </mc:Fallback>
+      </mc:AlternateContent>
+      <p:cxnSp>
+        <p:nvCxnSpPr>
+          <p:cNvPr id="6" name="Straight Arrow Connector 5">
+            <a:extLst>
+              <a:ext uri="{FF2B5EF4-FFF2-40B4-BE49-F238E27FC236}">
+                <a16:creationId xmlns:a16="http://schemas.microsoft.com/office/drawing/2014/main" id="{1872160D-45D9-DD25-0D95-5D4E71B8DC12}"/>
+              </a:ext>
+            </a:extLst>
+          </p:cNvPr>
+          <p:cNvCxnSpPr/>
+          <p:nvPr/>
+        </p:nvCxnSpPr>
+        <p:spPr>
+          <a:xfrm flipH="1">
+            <a:off x="2825750" y="4120549"/>
+            <a:ext cx="2313153" cy="0"/>
+          </a:xfrm>
+          <a:prstGeom prst="straightConnector1">
+            <a:avLst/>
+          </a:prstGeom>
+          <a:ln>
+            <a:solidFill>
+              <a:schemeClr val="tx2">
+                <a:lumMod val="75000"/>
+                <a:lumOff val="25000"/>
+              </a:schemeClr>
+            </a:solidFill>
+            <a:tailEnd type="triangle"/>
+          </a:ln>
+        </p:spPr>
+        <p:style>
+          <a:lnRef idx="2">
+            <a:schemeClr val="dk1"/>
+          </a:lnRef>
+          <a:fillRef idx="0">
+            <a:schemeClr val="dk1"/>
+          </a:fillRef>
+          <a:effectRef idx="1">
+            <a:schemeClr val="dk1"/>
+          </a:effectRef>
+          <a:fontRef idx="minor">
+            <a:schemeClr val="tx1"/>
+          </a:fontRef>
+        </p:style>
+      </p:cxnSp>
+      <mc:AlternateContent xmlns:mc="http://schemas.openxmlformats.org/markup-compatibility/2006">
+        <mc:Choice xmlns:a14="http://schemas.microsoft.com/office/drawing/2010/main" Requires="a14">
+          <p:sp>
+            <p:nvSpPr>
+              <p:cNvPr id="9" name="TextBox 8">
+                <a:extLst>
+                  <a:ext uri="{FF2B5EF4-FFF2-40B4-BE49-F238E27FC236}">
+                    <a16:creationId xmlns:a16="http://schemas.microsoft.com/office/drawing/2014/main" id="{C9CD7EE7-5221-C9BF-AE14-694C5FFE97CC}"/>
+                  </a:ext>
+                </a:extLst>
+              </p:cNvPr>
+              <p:cNvSpPr txBox="1"/>
+              <p:nvPr/>
+            </p:nvSpPr>
+            <p:spPr>
+              <a:xfrm>
+                <a:off x="4778167" y="4167399"/>
+                <a:ext cx="679865" cy="276999"/>
+              </a:xfrm>
+              <a:prstGeom prst="rect">
+                <a:avLst/>
+              </a:prstGeom>
+              <a:noFill/>
+              <a:ln>
+                <a:solidFill>
+                  <a:schemeClr val="tx2">
+                    <a:lumMod val="75000"/>
+                    <a:lumOff val="25000"/>
+                  </a:schemeClr>
+                </a:solidFill>
+              </a:ln>
+            </p:spPr>
+            <p:txBody>
+              <a:bodyPr wrap="none" lIns="0" tIns="0" rIns="0" bIns="0" rtlCol="0">
+                <a:spAutoFit/>
+              </a:bodyPr>
+              <a:lstStyle/>
+              <a:p>
+                <a14:m>
+                  <m:oMathPara xmlns:m="http://schemas.openxmlformats.org/officeDocument/2006/math">
+                    <m:oMathParaPr>
+                      <m:jc m:val="centerGroup"/>
+                    </m:oMathParaPr>
+                    <m:oMath xmlns:m="http://schemas.openxmlformats.org/officeDocument/2006/math">
+                      <m:sSub>
+                        <m:sSubPr>
+                          <m:ctrlPr>
+                            <a:rPr lang="en-US" b="0" i="1" smtClean="0">
+                              <a:solidFill>
+                                <a:schemeClr val="accent1">
+                                  <a:lumMod val="75000"/>
+                                </a:schemeClr>
+                              </a:solidFill>
+                              <a:latin typeface="Cambria Math" panose="02040503050406030204" pitchFamily="18" charset="0"/>
+                            </a:rPr>
+                          </m:ctrlPr>
+                        </m:sSubPr>
+                        <m:e>
+                          <m:r>
+                            <a:rPr lang="en-US" b="0" i="1" smtClean="0">
+                              <a:solidFill>
+                                <a:schemeClr val="accent1">
+                                  <a:lumMod val="75000"/>
+                                </a:schemeClr>
+                              </a:solidFill>
+                              <a:latin typeface="Cambria Math" panose="02040503050406030204" pitchFamily="18" charset="0"/>
+                            </a:rPr>
+                            <m:t>𝑠</m:t>
+                          </m:r>
+                        </m:e>
+                        <m:sub>
+                          <m:r>
+                            <a:rPr lang="en-US" b="0" i="1" smtClean="0">
+                              <a:solidFill>
+                                <a:schemeClr val="accent1">
+                                  <a:lumMod val="75000"/>
+                                </a:schemeClr>
+                              </a:solidFill>
+                              <a:latin typeface="Cambria Math" panose="02040503050406030204" pitchFamily="18" charset="0"/>
+                            </a:rPr>
+                            <m:t>1</m:t>
+                          </m:r>
+                        </m:sub>
+                      </m:sSub>
+                      <m:r>
+                        <a:rPr lang="en-US" b="0" i="1" smtClean="0">
+                          <a:solidFill>
+                            <a:schemeClr val="accent1">
+                              <a:lumMod val="75000"/>
+                            </a:schemeClr>
+                          </a:solidFill>
+                          <a:latin typeface="Cambria Math" panose="02040503050406030204" pitchFamily="18" charset="0"/>
+                        </a:rPr>
+                        <m:t>=0</m:t>
+                      </m:r>
+                    </m:oMath>
+                  </m:oMathPara>
+                </a14:m>
+                <a:endParaRPr lang="en-US" b="0" dirty="0">
+                  <a:solidFill>
+                    <a:schemeClr val="accent1">
+                      <a:lumMod val="75000"/>
+                    </a:schemeClr>
+                  </a:solidFill>
+                </a:endParaRPr>
+              </a:p>
+            </p:txBody>
+          </p:sp>
+        </mc:Choice>
+        <mc:Fallback>
+          <p:sp>
+            <p:nvSpPr>
+              <p:cNvPr id="9" name="TextBox 8">
+                <a:extLst>
+                  <a:ext uri="{FF2B5EF4-FFF2-40B4-BE49-F238E27FC236}">
+                    <a16:creationId xmlns:a16="http://schemas.microsoft.com/office/drawing/2014/main" id="{C9CD7EE7-5221-C9BF-AE14-694C5FFE97CC}"/>
+                  </a:ext>
+                </a:extLst>
+              </p:cNvPr>
+              <p:cNvSpPr txBox="1">
+                <a:spLocks noRot="1" noChangeAspect="1" noMove="1" noResize="1" noEditPoints="1" noAdjustHandles="1" noChangeArrowheads="1" noChangeShapeType="1" noTextEdit="1"/>
+              </p:cNvSpPr>
+              <p:nvPr/>
+            </p:nvSpPr>
+            <p:spPr>
+              <a:xfrm>
+                <a:off x="4778167" y="4167399"/>
+                <a:ext cx="679865" cy="276999"/>
+              </a:xfrm>
+              <a:prstGeom prst="rect">
+                <a:avLst/>
+              </a:prstGeom>
+              <a:blipFill>
+                <a:blip r:embed="rId11"/>
+                <a:stretch>
+                  <a:fillRect l="-4425" r="-7080" b="-12766"/>
                 </a:stretch>
               </a:blipFill>
               <a:ln>
                 <a:solidFill>
-                  <a:schemeClr val="bg2">
+                  <a:schemeClr val="tx2">
                     <a:lumMod val="75000"/>
+                    <a:lumOff val="25000"/>
                   </a:schemeClr>
                 </a:solidFill>
+              </a:ln>
+            </p:spPr>
+            <p:txBody>
+              <a:bodyPr/>
+              <a:lstStyle/>
+              <a:p>
+                <a:r>
+                  <a:rPr lang="en-US">
+                    <a:noFill/>
+                  </a:rPr>
+                  <a:t> </a:t>
+                </a:r>
+              </a:p>
+            </p:txBody>
+          </p:sp>
+        </mc:Fallback>
+      </mc:AlternateContent>
+      <mc:AlternateContent xmlns:mc="http://schemas.openxmlformats.org/markup-compatibility/2006">
+        <mc:Choice xmlns:a14="http://schemas.microsoft.com/office/drawing/2010/main" Requires="a14">
+          <p:sp>
+            <p:nvSpPr>
+              <p:cNvPr id="10" name="TextBox 9">
+                <a:extLst>
+                  <a:ext uri="{FF2B5EF4-FFF2-40B4-BE49-F238E27FC236}">
+                    <a16:creationId xmlns:a16="http://schemas.microsoft.com/office/drawing/2014/main" id="{DE24ADC8-ED32-0DE1-94D1-214D16560CCA}"/>
+                  </a:ext>
+                </a:extLst>
+              </p:cNvPr>
+              <p:cNvSpPr txBox="1"/>
+              <p:nvPr/>
+            </p:nvSpPr>
+            <p:spPr>
+              <a:xfrm>
+                <a:off x="3741852" y="4119866"/>
+                <a:ext cx="250261" cy="276999"/>
+              </a:xfrm>
+              <a:prstGeom prst="rect">
+                <a:avLst/>
+              </a:prstGeom>
+              <a:noFill/>
+              <a:ln>
+                <a:noFill/>
+              </a:ln>
+            </p:spPr>
+            <p:txBody>
+              <a:bodyPr wrap="none" lIns="0" tIns="0" rIns="0" bIns="0" rtlCol="0">
+                <a:spAutoFit/>
+              </a:bodyPr>
+              <a:lstStyle/>
+              <a:p>
+                <a14:m>
+                  <m:oMathPara xmlns:m="http://schemas.openxmlformats.org/officeDocument/2006/math">
+                    <m:oMathParaPr>
+                      <m:jc m:val="centerGroup"/>
+                    </m:oMathParaPr>
+                    <m:oMath xmlns:m="http://schemas.openxmlformats.org/officeDocument/2006/math">
+                      <m:sSub>
+                        <m:sSubPr>
+                          <m:ctrlPr>
+                            <a:rPr lang="en-US" b="0" i="1" smtClean="0">
+                              <a:solidFill>
+                                <a:schemeClr val="accent1">
+                                  <a:lumMod val="75000"/>
+                                </a:schemeClr>
+                              </a:solidFill>
+                              <a:latin typeface="Cambria Math" panose="02040503050406030204" pitchFamily="18" charset="0"/>
+                            </a:rPr>
+                          </m:ctrlPr>
+                        </m:sSubPr>
+                        <m:e>
+                          <m:r>
+                            <a:rPr lang="en-US" b="0" i="1" smtClean="0">
+                              <a:solidFill>
+                                <a:schemeClr val="accent1">
+                                  <a:lumMod val="75000"/>
+                                </a:schemeClr>
+                              </a:solidFill>
+                              <a:latin typeface="Cambria Math" panose="02040503050406030204" pitchFamily="18" charset="0"/>
+                            </a:rPr>
+                            <m:t>𝑠</m:t>
+                          </m:r>
+                        </m:e>
+                        <m:sub>
+                          <m:r>
+                            <a:rPr lang="en-US" b="0" i="1" smtClean="0">
+                              <a:solidFill>
+                                <a:schemeClr val="accent1">
+                                  <a:lumMod val="75000"/>
+                                </a:schemeClr>
+                              </a:solidFill>
+                              <a:latin typeface="Cambria Math" panose="02040503050406030204" pitchFamily="18" charset="0"/>
+                            </a:rPr>
+                            <m:t>1</m:t>
+                          </m:r>
+                        </m:sub>
+                      </m:sSub>
+                    </m:oMath>
+                  </m:oMathPara>
+                </a14:m>
+                <a:endParaRPr lang="en-US" b="0" dirty="0">
+                  <a:solidFill>
+                    <a:schemeClr val="accent1">
+                      <a:lumMod val="75000"/>
+                    </a:schemeClr>
+                  </a:solidFill>
+                </a:endParaRPr>
+              </a:p>
+            </p:txBody>
+          </p:sp>
+        </mc:Choice>
+        <mc:Fallback>
+          <p:sp>
+            <p:nvSpPr>
+              <p:cNvPr id="10" name="TextBox 9">
+                <a:extLst>
+                  <a:ext uri="{FF2B5EF4-FFF2-40B4-BE49-F238E27FC236}">
+                    <a16:creationId xmlns:a16="http://schemas.microsoft.com/office/drawing/2014/main" id="{DE24ADC8-ED32-0DE1-94D1-214D16560CCA}"/>
+                  </a:ext>
+                </a:extLst>
+              </p:cNvPr>
+              <p:cNvSpPr txBox="1">
+                <a:spLocks noRot="1" noChangeAspect="1" noMove="1" noResize="1" noEditPoints="1" noAdjustHandles="1" noChangeArrowheads="1" noChangeShapeType="1" noTextEdit="1"/>
+              </p:cNvSpPr>
+              <p:nvPr/>
+            </p:nvSpPr>
+            <p:spPr>
+              <a:xfrm>
+                <a:off x="3741852" y="4119866"/>
+                <a:ext cx="250261" cy="276999"/>
+              </a:xfrm>
+              <a:prstGeom prst="rect">
+                <a:avLst/>
+              </a:prstGeom>
+              <a:blipFill>
+                <a:blip r:embed="rId12"/>
+                <a:stretch>
+                  <a:fillRect l="-14634" r="-9756" b="-15556"/>
+                </a:stretch>
+              </a:blipFill>
+              <a:ln>
+                <a:noFill/>
+              </a:ln>
+            </p:spPr>
+            <p:txBody>
+              <a:bodyPr/>
+              <a:lstStyle/>
+              <a:p>
+                <a:r>
+                  <a:rPr lang="en-US">
+                    <a:noFill/>
+                  </a:rPr>
+                  <a:t> </a:t>
+                </a:r>
+              </a:p>
+            </p:txBody>
+          </p:sp>
+        </mc:Fallback>
+      </mc:AlternateContent>
+      <p:cxnSp>
+        <p:nvCxnSpPr>
+          <p:cNvPr id="13" name="Straight Arrow Connector 12">
+            <a:extLst>
+              <a:ext uri="{FF2B5EF4-FFF2-40B4-BE49-F238E27FC236}">
+                <a16:creationId xmlns:a16="http://schemas.microsoft.com/office/drawing/2014/main" id="{DA6DF715-88EC-E7FF-07C5-6C562EC39485}"/>
+              </a:ext>
+            </a:extLst>
+          </p:cNvPr>
+          <p:cNvCxnSpPr>
+            <a:cxnSpLocks/>
+          </p:cNvCxnSpPr>
+          <p:nvPr/>
+        </p:nvCxnSpPr>
+        <p:spPr>
+          <a:xfrm flipH="1">
+            <a:off x="548946" y="4119866"/>
+            <a:ext cx="2266761" cy="0"/>
+          </a:xfrm>
+          <a:prstGeom prst="straightConnector1">
+            <a:avLst/>
+          </a:prstGeom>
+          <a:ln>
+            <a:solidFill>
+              <a:schemeClr val="accent6">
+                <a:lumMod val="75000"/>
+              </a:schemeClr>
+            </a:solidFill>
+            <a:tailEnd type="triangle"/>
+          </a:ln>
+        </p:spPr>
+        <p:style>
+          <a:lnRef idx="2">
+            <a:schemeClr val="dk1"/>
+          </a:lnRef>
+          <a:fillRef idx="0">
+            <a:schemeClr val="dk1"/>
+          </a:fillRef>
+          <a:effectRef idx="1">
+            <a:schemeClr val="dk1"/>
+          </a:effectRef>
+          <a:fontRef idx="minor">
+            <a:schemeClr val="tx1"/>
+          </a:fontRef>
+        </p:style>
+      </p:cxnSp>
+      <mc:AlternateContent xmlns:mc="http://schemas.openxmlformats.org/markup-compatibility/2006">
+        <mc:Choice xmlns:a14="http://schemas.microsoft.com/office/drawing/2010/main" Requires="a14">
+          <p:sp>
+            <p:nvSpPr>
+              <p:cNvPr id="14" name="TextBox 13">
+                <a:extLst>
+                  <a:ext uri="{FF2B5EF4-FFF2-40B4-BE49-F238E27FC236}">
+                    <a16:creationId xmlns:a16="http://schemas.microsoft.com/office/drawing/2014/main" id="{16537C99-BDF5-8951-F4C8-5BC508E80865}"/>
+                  </a:ext>
+                </a:extLst>
+              </p:cNvPr>
+              <p:cNvSpPr txBox="1"/>
+              <p:nvPr/>
+            </p:nvSpPr>
+            <p:spPr>
+              <a:xfrm>
+                <a:off x="2438001" y="4167398"/>
+                <a:ext cx="685188" cy="276999"/>
+              </a:xfrm>
+              <a:prstGeom prst="rect">
+                <a:avLst/>
+              </a:prstGeom>
+              <a:noFill/>
+              <a:ln>
+                <a:noFill/>
+              </a:ln>
+            </p:spPr>
+            <p:txBody>
+              <a:bodyPr wrap="none" lIns="0" tIns="0" rIns="0" bIns="0" rtlCol="0">
+                <a:spAutoFit/>
+              </a:bodyPr>
+              <a:lstStyle/>
+              <a:p>
+                <a14:m>
+                  <m:oMathPara xmlns:m="http://schemas.openxmlformats.org/officeDocument/2006/math">
+                    <m:oMathParaPr>
+                      <m:jc m:val="centerGroup"/>
+                    </m:oMathParaPr>
+                    <m:oMath xmlns:m="http://schemas.openxmlformats.org/officeDocument/2006/math">
+                      <m:sSub>
+                        <m:sSubPr>
+                          <m:ctrlPr>
+                            <a:rPr lang="en-US" b="0" i="1" smtClean="0">
+                              <a:solidFill>
+                                <a:schemeClr val="accent6">
+                                  <a:lumMod val="75000"/>
+                                </a:schemeClr>
+                              </a:solidFill>
+                              <a:latin typeface="Cambria Math" panose="02040503050406030204" pitchFamily="18" charset="0"/>
+                            </a:rPr>
+                          </m:ctrlPr>
+                        </m:sSubPr>
+                        <m:e>
+                          <m:r>
+                            <a:rPr lang="en-US" b="0" i="1" smtClean="0">
+                              <a:solidFill>
+                                <a:schemeClr val="accent6">
+                                  <a:lumMod val="75000"/>
+                                </a:schemeClr>
+                              </a:solidFill>
+                              <a:latin typeface="Cambria Math" panose="02040503050406030204" pitchFamily="18" charset="0"/>
+                            </a:rPr>
+                            <m:t>𝑠</m:t>
+                          </m:r>
+                        </m:e>
+                        <m:sub>
+                          <m:r>
+                            <a:rPr lang="en-US" b="0" i="1" smtClean="0">
+                              <a:solidFill>
+                                <a:schemeClr val="accent6">
+                                  <a:lumMod val="75000"/>
+                                </a:schemeClr>
+                              </a:solidFill>
+                              <a:latin typeface="Cambria Math" panose="02040503050406030204" pitchFamily="18" charset="0"/>
+                            </a:rPr>
+                            <m:t>2</m:t>
+                          </m:r>
+                        </m:sub>
+                      </m:sSub>
+                      <m:r>
+                        <a:rPr lang="en-US" b="0" i="1" smtClean="0">
+                          <a:solidFill>
+                            <a:schemeClr val="accent6">
+                              <a:lumMod val="75000"/>
+                            </a:schemeClr>
+                          </a:solidFill>
+                          <a:latin typeface="Cambria Math" panose="02040503050406030204" pitchFamily="18" charset="0"/>
+                        </a:rPr>
+                        <m:t>=0</m:t>
+                      </m:r>
+                    </m:oMath>
+                  </m:oMathPara>
+                </a14:m>
+                <a:endParaRPr lang="en-US" b="0" dirty="0">
+                  <a:solidFill>
+                    <a:schemeClr val="accent6">
+                      <a:lumMod val="75000"/>
+                    </a:schemeClr>
+                  </a:solidFill>
+                </a:endParaRPr>
+              </a:p>
+            </p:txBody>
+          </p:sp>
+        </mc:Choice>
+        <mc:Fallback>
+          <p:sp>
+            <p:nvSpPr>
+              <p:cNvPr id="14" name="TextBox 13">
+                <a:extLst>
+                  <a:ext uri="{FF2B5EF4-FFF2-40B4-BE49-F238E27FC236}">
+                    <a16:creationId xmlns:a16="http://schemas.microsoft.com/office/drawing/2014/main" id="{16537C99-BDF5-8951-F4C8-5BC508E80865}"/>
+                  </a:ext>
+                </a:extLst>
+              </p:cNvPr>
+              <p:cNvSpPr txBox="1">
+                <a:spLocks noRot="1" noChangeAspect="1" noMove="1" noResize="1" noEditPoints="1" noAdjustHandles="1" noChangeArrowheads="1" noChangeShapeType="1" noTextEdit="1"/>
+              </p:cNvSpPr>
+              <p:nvPr/>
+            </p:nvSpPr>
+            <p:spPr>
+              <a:xfrm>
+                <a:off x="2438001" y="4167398"/>
+                <a:ext cx="685188" cy="276999"/>
+              </a:xfrm>
+              <a:prstGeom prst="rect">
+                <a:avLst/>
+              </a:prstGeom>
+              <a:blipFill>
+                <a:blip r:embed="rId13"/>
+                <a:stretch>
+                  <a:fillRect l="-5357" r="-8036" b="-15556"/>
+                </a:stretch>
+              </a:blipFill>
+              <a:ln>
+                <a:noFill/>
+              </a:ln>
+            </p:spPr>
+            <p:txBody>
+              <a:bodyPr/>
+              <a:lstStyle/>
+              <a:p>
+                <a:r>
+                  <a:rPr lang="en-US">
+                    <a:noFill/>
+                  </a:rPr>
+                  <a:t> </a:t>
+                </a:r>
+              </a:p>
+            </p:txBody>
+          </p:sp>
+        </mc:Fallback>
+      </mc:AlternateContent>
+      <mc:AlternateContent xmlns:mc="http://schemas.openxmlformats.org/markup-compatibility/2006">
+        <mc:Choice xmlns:a14="http://schemas.microsoft.com/office/drawing/2010/main" Requires="a14">
+          <p:sp>
+            <p:nvSpPr>
+              <p:cNvPr id="16" name="TextBox 15">
+                <a:extLst>
+                  <a:ext uri="{FF2B5EF4-FFF2-40B4-BE49-F238E27FC236}">
+                    <a16:creationId xmlns:a16="http://schemas.microsoft.com/office/drawing/2014/main" id="{C9935E13-F2E3-519C-3E38-4AC23A4DA243}"/>
+                  </a:ext>
+                </a:extLst>
+              </p:cNvPr>
+              <p:cNvSpPr txBox="1"/>
+              <p:nvPr/>
+            </p:nvSpPr>
+            <p:spPr>
+              <a:xfrm>
+                <a:off x="555933" y="4106349"/>
+                <a:ext cx="255583" cy="276999"/>
+              </a:xfrm>
+              <a:prstGeom prst="rect">
+                <a:avLst/>
+              </a:prstGeom>
+              <a:noFill/>
+              <a:ln>
+                <a:noFill/>
+              </a:ln>
+            </p:spPr>
+            <p:txBody>
+              <a:bodyPr wrap="none" lIns="0" tIns="0" rIns="0" bIns="0" rtlCol="0">
+                <a:spAutoFit/>
+              </a:bodyPr>
+              <a:lstStyle/>
+              <a:p>
+                <a14:m>
+                  <m:oMathPara xmlns:m="http://schemas.openxmlformats.org/officeDocument/2006/math">
+                    <m:oMathParaPr>
+                      <m:jc m:val="centerGroup"/>
+                    </m:oMathParaPr>
+                    <m:oMath xmlns:m="http://schemas.openxmlformats.org/officeDocument/2006/math">
+                      <m:sSub>
+                        <m:sSubPr>
+                          <m:ctrlPr>
+                            <a:rPr lang="en-US" b="0" i="1" smtClean="0">
+                              <a:solidFill>
+                                <a:schemeClr val="accent6">
+                                  <a:lumMod val="75000"/>
+                                </a:schemeClr>
+                              </a:solidFill>
+                              <a:latin typeface="Cambria Math" panose="02040503050406030204" pitchFamily="18" charset="0"/>
+                            </a:rPr>
+                          </m:ctrlPr>
+                        </m:sSubPr>
+                        <m:e>
+                          <m:r>
+                            <a:rPr lang="en-US" b="0" i="1" smtClean="0">
+                              <a:solidFill>
+                                <a:schemeClr val="accent6">
+                                  <a:lumMod val="75000"/>
+                                </a:schemeClr>
+                              </a:solidFill>
+                              <a:latin typeface="Cambria Math" panose="02040503050406030204" pitchFamily="18" charset="0"/>
+                            </a:rPr>
+                            <m:t>𝑠</m:t>
+                          </m:r>
+                        </m:e>
+                        <m:sub>
+                          <m:r>
+                            <a:rPr lang="en-US" b="0" i="1" smtClean="0">
+                              <a:solidFill>
+                                <a:schemeClr val="accent6">
+                                  <a:lumMod val="75000"/>
+                                </a:schemeClr>
+                              </a:solidFill>
+                              <a:latin typeface="Cambria Math" panose="02040503050406030204" pitchFamily="18" charset="0"/>
+                            </a:rPr>
+                            <m:t>2</m:t>
+                          </m:r>
+                        </m:sub>
+                      </m:sSub>
+                    </m:oMath>
+                  </m:oMathPara>
+                </a14:m>
+                <a:endParaRPr lang="en-US" b="0" dirty="0">
+                  <a:solidFill>
+                    <a:schemeClr val="accent6">
+                      <a:lumMod val="75000"/>
+                    </a:schemeClr>
+                  </a:solidFill>
+                </a:endParaRPr>
+              </a:p>
+            </p:txBody>
+          </p:sp>
+        </mc:Choice>
+        <mc:Fallback>
+          <p:sp>
+            <p:nvSpPr>
+              <p:cNvPr id="16" name="TextBox 15">
+                <a:extLst>
+                  <a:ext uri="{FF2B5EF4-FFF2-40B4-BE49-F238E27FC236}">
+                    <a16:creationId xmlns:a16="http://schemas.microsoft.com/office/drawing/2014/main" id="{C9935E13-F2E3-519C-3E38-4AC23A4DA243}"/>
+                  </a:ext>
+                </a:extLst>
+              </p:cNvPr>
+              <p:cNvSpPr txBox="1">
+                <a:spLocks noRot="1" noChangeAspect="1" noMove="1" noResize="1" noEditPoints="1" noAdjustHandles="1" noChangeArrowheads="1" noChangeShapeType="1" noTextEdit="1"/>
+              </p:cNvSpPr>
+              <p:nvPr/>
+            </p:nvSpPr>
+            <p:spPr>
+              <a:xfrm>
+                <a:off x="555933" y="4106349"/>
+                <a:ext cx="255583" cy="276999"/>
+              </a:xfrm>
+              <a:prstGeom prst="rect">
+                <a:avLst/>
+              </a:prstGeom>
+              <a:blipFill>
+                <a:blip r:embed="rId14"/>
+                <a:stretch>
+                  <a:fillRect l="-14286" r="-9524" b="-15556"/>
+                </a:stretch>
+              </a:blipFill>
+              <a:ln>
+                <a:noFill/>
               </a:ln>
             </p:spPr>
             <p:txBody>

</xml_diff>